<commit_message>
embed real SWaT testbed photos + Paper #9 diagram into deck (7 slides updated)
</commit_message>
<xml_diff>
--- a/slides/swat_with_images.pptx
+++ b/slides/swat_with_images.pptx
@@ -2845,6 +2845,64 @@
           </a:p>
         </p:txBody>
       </p:sp>
+      <p:pic>
+        <p:nvPicPr>
+          <p:cNvPr id="15" name="Picture 14" descr="swat_testbed_photo.jpg"/>
+          <p:cNvPicPr>
+            <a:picLocks noChangeAspect="1"/>
+          </p:cNvPicPr>
+          <p:nvPr/>
+        </p:nvPicPr>
+        <p:blipFill>
+          <a:blip r:embed="rId3"/>
+          <a:stretch>
+            <a:fillRect/>
+          </a:stretch>
+        </p:blipFill>
+        <p:spPr>
+          <a:xfrm>
+            <a:off x="0" y="5303520"/>
+            <a:ext cx="9144000" cy="1600200"/>
+          </a:xfrm>
+          <a:prstGeom prst="rect">
+            <a:avLst/>
+          </a:prstGeom>
+        </p:spPr>
+      </p:pic>
+      <p:sp>
+        <p:nvSpPr>
+          <p:cNvPr id="16" name="TextBox 15"/>
+          <p:cNvSpPr txBox="1"/>
+          <p:nvPr/>
+        </p:nvSpPr>
+        <p:spPr>
+          <a:xfrm>
+            <a:off x="91440" y="6858000"/>
+            <a:ext cx="8961120" cy="256032"/>
+          </a:xfrm>
+          <a:prstGeom prst="rect">
+            <a:avLst/>
+          </a:prstGeom>
+          <a:noFill/>
+        </p:spPr>
+        <p:txBody>
+          <a:bodyPr wrap="none">
+            <a:spAutoFit/>
+          </a:bodyPr>
+          <a:lstStyle/>
+          <a:p>
+            <a:pPr algn="ctr"/>
+            <a:r>
+              <a:rPr sz="900" i="1">
+                <a:solidFill>
+                  <a:srgbClr val="7090B0"/>
+                </a:solidFill>
+              </a:rPr>
+              <a:t>SWaT Testbed — iTrust Centre for Research in Cyber Security, SUTD Singapore</a:t>
+            </a:r>
+          </a:p>
+        </p:txBody>
+      </p:sp>
     </p:spTree>
   </p:cSld>
   <p:clrMapOvr>
@@ -5537,30 +5595,6 @@
           </a:p>
         </p:txBody>
       </p:sp>
-      <p:pic>
-        <p:nvPicPr>
-          <p:cNvPr id="4" name="Image 0" descr="preencoded.png"/>
-          <p:cNvPicPr>
-            <a:picLocks noChangeAspect="1"/>
-          </p:cNvPicPr>
-          <p:nvPr/>
-        </p:nvPicPr>
-        <p:blipFill>
-          <a:blip r:embed="rId1"/>
-          <a:stretch>
-            <a:fillRect/>
-          </a:stretch>
-        </p:blipFill>
-        <p:spPr>
-          <a:xfrm>
-            <a:off x="182880" y="987552"/>
-            <a:ext cx="8778240" cy="3657600"/>
-          </a:xfrm>
-          <a:prstGeom prst="rect">
-            <a:avLst/>
-          </a:prstGeom>
-        </p:spPr>
-      </p:pic>
       <p:sp>
         <p:nvSpPr>
           <p:cNvPr id="5" name="Shape 2"/>
@@ -5625,24 +5659,58 @@
           </a:p>
         </p:txBody>
       </p:sp>
+      <p:sp>
+        <p:nvSpPr>
+          <p:cNvPr id="8" name="TextBox 7"/>
+          <p:cNvSpPr txBox="1"/>
+          <p:nvPr/>
+        </p:nvSpPr>
+        <p:spPr>
+          <a:xfrm>
+            <a:off x="137160" y="6537960"/>
+            <a:ext cx="8869680" cy="274320"/>
+          </a:xfrm>
+          <a:prstGeom prst="rect">
+            <a:avLst/>
+          </a:prstGeom>
+          <a:noFill/>
+        </p:spPr>
+        <p:txBody>
+          <a:bodyPr wrap="square">
+            <a:spAutoFit/>
+          </a:bodyPr>
+          <a:lstStyle/>
+          <a:p>
+            <a:pPr algn="ctr"/>
+            <a:r>
+              <a:rPr sz="1000" i="1">
+                <a:solidFill>
+                  <a:srgbClr val="90B4CE"/>
+                </a:solidFill>
+              </a:rPr>
+              <a:t>Attack surface: Attacker on Zone D → ARP poison HMI↔PLC1A → Modbus false command injection</a:t>
+            </a:r>
+          </a:p>
+        </p:txBody>
+      </p:sp>
       <p:pic>
         <p:nvPicPr>
-          <p:cNvPr id="7" name="Picture 6" descr="img_attack_surface.png"/>
+          <p:cNvPr id="9" name="Picture 8" descr="swat_p1_stage.png"/>
           <p:cNvPicPr>
             <a:picLocks noChangeAspect="1"/>
           </p:cNvPicPr>
           <p:nvPr/>
         </p:nvPicPr>
         <p:blipFill>
-          <a:blip r:embed="rId4"/>
+          <a:blip r:embed="rId5"/>
           <a:stretch>
             <a:fillRect/>
           </a:stretch>
         </p:blipFill>
         <p:spPr>
           <a:xfrm>
-            <a:off x="137160" y="3840480"/>
-            <a:ext cx="8869680" cy="2743200"/>
+            <a:off x="137160" y="1097280"/>
+            <a:ext cx="5486400" cy="2377440"/>
           </a:xfrm>
           <a:prstGeom prst="rect">
             <a:avLst/>
@@ -5651,34 +5719,92 @@
       </p:pic>
       <p:sp>
         <p:nvSpPr>
-          <p:cNvPr id="8" name="TextBox 7"/>
+          <p:cNvPr id="10" name="TextBox 9"/>
           <p:cNvSpPr txBox="1"/>
           <p:nvPr/>
         </p:nvSpPr>
         <p:spPr>
           <a:xfrm>
-            <a:off x="137160" y="6537960"/>
-            <a:ext cx="8869680" cy="274320"/>
-          </a:xfrm>
-          <a:prstGeom prst="rect">
-            <a:avLst/>
-          </a:prstGeom>
-          <a:noFill/>
-        </p:spPr>
-        <p:txBody>
-          <a:bodyPr wrap="square">
+            <a:off x="137160" y="3429000"/>
+            <a:ext cx="5486400" cy="256032"/>
+          </a:xfrm>
+          <a:prstGeom prst="rect">
+            <a:avLst/>
+          </a:prstGeom>
+          <a:noFill/>
+        </p:spPr>
+        <p:txBody>
+          <a:bodyPr wrap="none">
             <a:spAutoFit/>
           </a:bodyPr>
           <a:lstStyle/>
           <a:p>
             <a:pPr algn="ctr"/>
             <a:r>
-              <a:rPr sz="1000" i="1">
-                <a:solidFill>
-                  <a:srgbClr val="90B4CE"/>
-                </a:solidFill>
-              </a:rPr>
-              <a:t>Attack surface: Attacker on Zone D → ARP poison HMI↔PLC1A → Modbus false command injection</a:t>
+              <a:rPr sz="900" i="1">
+                <a:solidFill>
+                  <a:srgbClr val="7090B0"/>
+                </a:solidFill>
+              </a:rPr>
+              <a:t>SWaT P&amp;ID — P1 raw water intake with MV101, T101, P101/P102, FIT101, LIT101</a:t>
+            </a:r>
+          </a:p>
+        </p:txBody>
+      </p:sp>
+      <p:pic>
+        <p:nvPicPr>
+          <p:cNvPr id="11" name="Picture 10" descr="swat_testbed_photo.jpg"/>
+          <p:cNvPicPr>
+            <a:picLocks noChangeAspect="1"/>
+          </p:cNvPicPr>
+          <p:nvPr/>
+        </p:nvPicPr>
+        <p:blipFill>
+          <a:blip r:embed="rId6"/>
+          <a:stretch>
+            <a:fillRect/>
+          </a:stretch>
+        </p:blipFill>
+        <p:spPr>
+          <a:xfrm>
+            <a:off x="5760720" y="1097280"/>
+            <a:ext cx="3246120" cy="2377440"/>
+          </a:xfrm>
+          <a:prstGeom prst="rect">
+            <a:avLst/>
+          </a:prstGeom>
+        </p:spPr>
+      </p:pic>
+      <p:sp>
+        <p:nvSpPr>
+          <p:cNvPr id="12" name="TextBox 11"/>
+          <p:cNvSpPr txBox="1"/>
+          <p:nvPr/>
+        </p:nvSpPr>
+        <p:spPr>
+          <a:xfrm>
+            <a:off x="5760720" y="3429000"/>
+            <a:ext cx="3246120" cy="256032"/>
+          </a:xfrm>
+          <a:prstGeom prst="rect">
+            <a:avLst/>
+          </a:prstGeom>
+          <a:noFill/>
+        </p:spPr>
+        <p:txBody>
+          <a:bodyPr wrap="none">
+            <a:spAutoFit/>
+          </a:bodyPr>
+          <a:lstStyle/>
+          <a:p>
+            <a:pPr algn="ctr"/>
+            <a:r>
+              <a:rPr sz="900" i="1">
+                <a:solidFill>
+                  <a:srgbClr val="7090B0"/>
+                </a:solidFill>
+              </a:rPr>
+              <a:t>Physical SWaT testbed at iTrust Lab</a:t>
             </a:r>
           </a:p>
         </p:txBody>
@@ -7026,16 +7152,50 @@
           </a:p>
         </p:txBody>
       </p:sp>
+      <p:sp>
+        <p:nvSpPr>
+          <p:cNvPr id="42" name="TextBox 41"/>
+          <p:cNvSpPr txBox="1"/>
+          <p:nvPr/>
+        </p:nvSpPr>
+        <p:spPr>
+          <a:xfrm>
+            <a:off x="137160" y="4114800"/>
+            <a:ext cx="5303520" cy="274320"/>
+          </a:xfrm>
+          <a:prstGeom prst="rect">
+            <a:avLst/>
+          </a:prstGeom>
+          <a:noFill/>
+        </p:spPr>
+        <p:txBody>
+          <a:bodyPr wrap="square">
+            <a:spAutoFit/>
+          </a:bodyPr>
+          <a:lstStyle/>
+          <a:p>
+            <a:pPr algn="ctr"/>
+            <a:r>
+              <a:rPr sz="1000" i="1">
+                <a:solidFill>
+                  <a:srgbClr val="90B4CE"/>
+                </a:solidFill>
+              </a:rPr>
+              <a:t>Network topology showing attacker path from Zone D → Zone B (OT) via Modbus TCP</a:t>
+            </a:r>
+          </a:p>
+        </p:txBody>
+      </p:sp>
       <p:pic>
         <p:nvPicPr>
-          <p:cNvPr id="41" name="Picture 40" descr="img_attack_surface.png"/>
+          <p:cNvPr id="43" name="Picture 42" descr="swat_architecture.png"/>
           <p:cNvPicPr>
             <a:picLocks noChangeAspect="1"/>
           </p:cNvPicPr>
           <p:nvPr/>
         </p:nvPicPr>
         <p:blipFill>
-          <a:blip r:embed="rId3"/>
+          <a:blip r:embed="rId4"/>
           <a:stretch>
             <a:fillRect/>
           </a:stretch>
@@ -7043,7 +7203,7 @@
         <p:spPr>
           <a:xfrm>
             <a:off x="137160" y="822960"/>
-            <a:ext cx="5303520" cy="3291840"/>
+            <a:ext cx="5120640" cy="3657600"/>
           </a:xfrm>
           <a:prstGeom prst="rect">
             <a:avLst/>
@@ -7052,34 +7212,34 @@
       </p:pic>
       <p:sp>
         <p:nvSpPr>
-          <p:cNvPr id="42" name="TextBox 41"/>
+          <p:cNvPr id="44" name="TextBox 43"/>
           <p:cNvSpPr txBox="1"/>
           <p:nvPr/>
         </p:nvSpPr>
         <p:spPr>
           <a:xfrm>
-            <a:off x="137160" y="4114800"/>
-            <a:ext cx="5303520" cy="274320"/>
-          </a:xfrm>
-          <a:prstGeom prst="rect">
-            <a:avLst/>
-          </a:prstGeom>
-          <a:noFill/>
-        </p:spPr>
-        <p:txBody>
-          <a:bodyPr wrap="square">
+            <a:off x="137160" y="4434840"/>
+            <a:ext cx="5120640" cy="256032"/>
+          </a:xfrm>
+          <a:prstGeom prst="rect">
+            <a:avLst/>
+          </a:prstGeom>
+          <a:noFill/>
+        </p:spPr>
+        <p:txBody>
+          <a:bodyPr wrap="none">
             <a:spAutoFit/>
           </a:bodyPr>
           <a:lstStyle/>
           <a:p>
             <a:pPr algn="ctr"/>
             <a:r>
-              <a:rPr sz="1000" i="1">
-                <a:solidFill>
-                  <a:srgbClr val="90B4CE"/>
-                </a:solidFill>
-              </a:rPr>
-              <a:t>Network topology showing attacker path from Zone D → Zone B (OT) via Modbus TCP</a:t>
+              <a:rPr sz="900" i="1">
+                <a:solidFill>
+                  <a:srgbClr val="7090B0"/>
+                </a:solidFill>
+              </a:rPr>
+              <a:t>SWaT network zones: attacker enters Zone D (IT), targets Zone A (OT/PLC1) via Modbus TCP</a:t>
             </a:r>
           </a:p>
         </p:txBody>
@@ -8434,6 +8594,64 @@
           </a:p>
         </p:txBody>
       </p:sp>
+      <p:pic>
+        <p:nvPicPr>
+          <p:cNvPr id="40" name="Picture 39" descr="paper9_attack_diagram.png"/>
+          <p:cNvPicPr>
+            <a:picLocks noChangeAspect="1"/>
+          </p:cNvPicPr>
+          <p:nvPr/>
+        </p:nvPicPr>
+        <p:blipFill>
+          <a:blip r:embed="rId3"/>
+          <a:stretch>
+            <a:fillRect/>
+          </a:stretch>
+        </p:blipFill>
+        <p:spPr>
+          <a:xfrm>
+            <a:off x="4754880" y="1097280"/>
+            <a:ext cx="4251960" cy="2560320"/>
+          </a:xfrm>
+          <a:prstGeom prst="rect">
+            <a:avLst/>
+          </a:prstGeom>
+        </p:spPr>
+      </p:pic>
+      <p:sp>
+        <p:nvSpPr>
+          <p:cNvPr id="41" name="TextBox 40"/>
+          <p:cNvSpPr txBox="1"/>
+          <p:nvPr/>
+        </p:nvSpPr>
+        <p:spPr>
+          <a:xfrm>
+            <a:off x="4754880" y="3611880"/>
+            <a:ext cx="4251960" cy="256032"/>
+          </a:xfrm>
+          <a:prstGeom prst="rect">
+            <a:avLst/>
+          </a:prstGeom>
+          <a:noFill/>
+        </p:spPr>
+        <p:txBody>
+          <a:bodyPr wrap="none">
+            <a:spAutoFit/>
+          </a:bodyPr>
+          <a:lstStyle/>
+          <a:p>
+            <a:pPr algn="ctr"/>
+            <a:r>
+              <a:rPr sz="900" i="1">
+                <a:solidFill>
+                  <a:srgbClr val="7090B0"/>
+                </a:solidFill>
+              </a:rPr>
+              <a:t>Fig. 2 from Paper #9 — Modbus TCP/IP ADU frame format (Alsabbagh et al., IEEE CCNC 2023)</a:t>
+            </a:r>
+          </a:p>
+        </p:txBody>
+      </p:sp>
     </p:spTree>
   </p:cSld>
   <p:clrMapOvr>
@@ -9431,6 +9649,64 @@
           </a:p>
         </p:txBody>
       </p:sp>
+      <p:pic>
+        <p:nvPicPr>
+          <p:cNvPr id="27" name="Picture 26" descr="paper9_attack_diagram.png"/>
+          <p:cNvPicPr>
+            <a:picLocks noChangeAspect="1"/>
+          </p:cNvPicPr>
+          <p:nvPr/>
+        </p:nvPicPr>
+        <p:blipFill>
+          <a:blip r:embed="rId3"/>
+          <a:stretch>
+            <a:fillRect/>
+          </a:stretch>
+        </p:blipFill>
+        <p:spPr>
+          <a:xfrm>
+            <a:off x="4754880" y="1371600"/>
+            <a:ext cx="4251960" cy="2377440"/>
+          </a:xfrm>
+          <a:prstGeom prst="rect">
+            <a:avLst/>
+          </a:prstGeom>
+        </p:spPr>
+      </p:pic>
+      <p:sp>
+        <p:nvSpPr>
+          <p:cNvPr id="28" name="TextBox 27"/>
+          <p:cNvSpPr txBox="1"/>
+          <p:nvPr/>
+        </p:nvSpPr>
+        <p:spPr>
+          <a:xfrm>
+            <a:off x="4754880" y="3703320"/>
+            <a:ext cx="4251960" cy="256032"/>
+          </a:xfrm>
+          <a:prstGeom prst="rect">
+            <a:avLst/>
+          </a:prstGeom>
+          <a:noFill/>
+        </p:spPr>
+        <p:txBody>
+          <a:bodyPr wrap="none">
+            <a:spAutoFit/>
+          </a:bodyPr>
+          <a:lstStyle/>
+          <a:p>
+            <a:pPr algn="ctr"/>
+            <a:r>
+              <a:rPr sz="900" i="1">
+                <a:solidFill>
+                  <a:srgbClr val="7090B0"/>
+                </a:solidFill>
+              </a:rPr>
+              <a:t>Replay key: (TransactionID + UnitID + FunctionCode) — Paper #9 Algorithm 1</a:t>
+            </a:r>
+          </a:p>
+        </p:txBody>
+      </p:sp>
     </p:spTree>
   </p:cSld>
   <p:clrMapOvr>
@@ -14731,24 +15007,58 @@
           </a:p>
         </p:txBody>
       </p:sp>
+      <p:sp>
+        <p:nvSpPr>
+          <p:cNvPr id="29" name="TextBox 28"/>
+          <p:cNvSpPr txBox="1"/>
+          <p:nvPr/>
+        </p:nvSpPr>
+        <p:spPr>
+          <a:xfrm>
+            <a:off x="137160" y="6675120"/>
+            <a:ext cx="8869680" cy="228600"/>
+          </a:xfrm>
+          <a:prstGeom prst="rect">
+            <a:avLst/>
+          </a:prstGeom>
+          <a:noFill/>
+        </p:spPr>
+        <p:txBody>
+          <a:bodyPr wrap="none">
+            <a:spAutoFit/>
+          </a:bodyPr>
+          <a:lstStyle/>
+          <a:p>
+            <a:pPr algn="ctr"/>
+            <a:r>
+              <a:rPr sz="900" i="1">
+                <a:solidFill>
+                  <a:srgbClr val="90B4CE"/>
+                </a:solidFill>
+              </a:rPr>
+              <a:t>SWaT Testbed — 6-stage water treatment process, PLC1–PLC6, iTrust Lab SUTD</a:t>
+            </a:r>
+          </a:p>
+        </p:txBody>
+      </p:sp>
       <p:pic>
         <p:nvPicPr>
-          <p:cNvPr id="28" name="Picture 27" descr="image.png"/>
+          <p:cNvPr id="30" name="Picture 29" descr="swat_testbed_photo.jpg"/>
           <p:cNvPicPr>
             <a:picLocks noChangeAspect="1"/>
           </p:cNvPicPr>
           <p:nvPr/>
         </p:nvPicPr>
         <p:blipFill>
-          <a:blip r:embed="rId3"/>
+          <a:blip r:embed="rId4"/>
           <a:stretch>
             <a:fillRect/>
           </a:stretch>
         </p:blipFill>
         <p:spPr>
           <a:xfrm>
-            <a:off x="137160" y="5029200"/>
-            <a:ext cx="8869680" cy="1691640"/>
+            <a:off x="137160" y="4846320"/>
+            <a:ext cx="8869680" cy="1783080"/>
           </a:xfrm>
           <a:prstGeom prst="rect">
             <a:avLst/>
@@ -14757,14 +15067,14 @@
       </p:pic>
       <p:sp>
         <p:nvSpPr>
-          <p:cNvPr id="29" name="TextBox 28"/>
+          <p:cNvPr id="31" name="TextBox 30"/>
           <p:cNvSpPr txBox="1"/>
           <p:nvPr/>
         </p:nvSpPr>
         <p:spPr>
           <a:xfrm>
-            <a:off x="137160" y="6675120"/>
-            <a:ext cx="8869680" cy="228600"/>
+            <a:off x="137160" y="6583680"/>
+            <a:ext cx="8869680" cy="256032"/>
           </a:xfrm>
           <a:prstGeom prst="rect">
             <a:avLst/>
@@ -14781,7 +15091,7 @@
             <a:r>
               <a:rPr sz="900" i="1">
                 <a:solidFill>
-                  <a:srgbClr val="90B4CE"/>
+                  <a:srgbClr val="7090B0"/>
                 </a:solidFill>
               </a:rPr>
               <a:t>SWaT Testbed — 6-stage water treatment process, PLC1–PLC6, iTrust Lab SUTD</a:t>
@@ -34844,6 +35154,64 @@
           </a:p>
         </p:txBody>
       </p:sp>
+      <p:pic>
+        <p:nvPicPr>
+          <p:cNvPr id="30" name="Picture 29" descr="swat_architecture.png"/>
+          <p:cNvPicPr>
+            <a:picLocks noChangeAspect="1"/>
+          </p:cNvPicPr>
+          <p:nvPr/>
+        </p:nvPicPr>
+        <p:blipFill>
+          <a:blip r:embed="rId3"/>
+          <a:stretch>
+            <a:fillRect/>
+          </a:stretch>
+        </p:blipFill>
+        <p:spPr>
+          <a:xfrm>
+            <a:off x="137160" y="1097280"/>
+            <a:ext cx="4389120" cy="3840480"/>
+          </a:xfrm>
+          <a:prstGeom prst="rect">
+            <a:avLst/>
+          </a:prstGeom>
+        </p:spPr>
+      </p:pic>
+      <p:sp>
+        <p:nvSpPr>
+          <p:cNvPr id="31" name="TextBox 30"/>
+          <p:cNvSpPr txBox="1"/>
+          <p:nvPr/>
+        </p:nvSpPr>
+        <p:spPr>
+          <a:xfrm>
+            <a:off x="137160" y="4892040"/>
+            <a:ext cx="4389120" cy="256032"/>
+          </a:xfrm>
+          <a:prstGeom prst="rect">
+            <a:avLst/>
+          </a:prstGeom>
+          <a:noFill/>
+        </p:spPr>
+        <p:txBody>
+          <a:bodyPr wrap="none">
+            <a:spAutoFit/>
+          </a:bodyPr>
+          <a:lstStyle/>
+          <a:p>
+            <a:pPr algn="ctr"/>
+            <a:r>
+              <a:rPr sz="900" i="1">
+                <a:solidFill>
+                  <a:srgbClr val="7090B0"/>
+                </a:solidFill>
+              </a:rPr>
+              <a:t>SWaT network architecture: IT (Level 2-3) + OT (Level 0-1), PLC1–PLC6</a:t>
+            </a:r>
+          </a:p>
+        </p:txBody>
+      </p:sp>
     </p:spTree>
   </p:cSld>
   <p:clrMapOvr>
@@ -35597,24 +35965,58 @@
           </a:p>
         </p:txBody>
       </p:sp>
+      <p:sp>
+        <p:nvSpPr>
+          <p:cNvPr id="24" name="TextBox 23"/>
+          <p:cNvSpPr txBox="1"/>
+          <p:nvPr/>
+        </p:nvSpPr>
+        <p:spPr>
+          <a:xfrm>
+            <a:off x="182880" y="6629400"/>
+            <a:ext cx="8778240" cy="274320"/>
+          </a:xfrm>
+          <a:prstGeom prst="rect">
+            <a:avLst/>
+          </a:prstGeom>
+          <a:noFill/>
+        </p:spPr>
+        <p:txBody>
+          <a:bodyPr wrap="square">
+            <a:spAutoFit/>
+          </a:bodyPr>
+          <a:lstStyle/>
+          <a:p>
+            <a:pPr algn="ctr"/>
+            <a:r>
+              <a:rPr sz="1000" i="1">
+                <a:solidFill>
+                  <a:srgbClr val="90B4CE"/>
+                </a:solidFill>
+              </a:rPr>
+              <a:t>SWaT testbed: 6-stage water treatment system targeted in this research</a:t>
+            </a:r>
+          </a:p>
+        </p:txBody>
+      </p:sp>
       <p:pic>
         <p:nvPicPr>
-          <p:cNvPr id="23" name="Picture 22" descr="img_swat_physical.png"/>
+          <p:cNvPr id="25" name="Picture 24" descr="swat_testbed_photo.jpg"/>
           <p:cNvPicPr>
             <a:picLocks noChangeAspect="1"/>
           </p:cNvPicPr>
           <p:nvPr/>
         </p:nvPicPr>
         <p:blipFill>
-          <a:blip r:embed="rId2"/>
+          <a:blip r:embed="rId3"/>
           <a:stretch>
             <a:fillRect/>
           </a:stretch>
         </p:blipFill>
         <p:spPr>
           <a:xfrm>
-            <a:off x="182880" y="3474720"/>
-            <a:ext cx="8778240" cy="3200400"/>
+            <a:off x="137160" y="3657600"/>
+            <a:ext cx="8869680" cy="2971800"/>
           </a:xfrm>
           <a:prstGeom prst="rect">
             <a:avLst/>
@@ -35623,34 +36025,34 @@
       </p:pic>
       <p:sp>
         <p:nvSpPr>
-          <p:cNvPr id="24" name="TextBox 23"/>
+          <p:cNvPr id="26" name="TextBox 25"/>
           <p:cNvSpPr txBox="1"/>
           <p:nvPr/>
         </p:nvSpPr>
         <p:spPr>
           <a:xfrm>
-            <a:off x="182880" y="6629400"/>
-            <a:ext cx="8778240" cy="274320"/>
-          </a:xfrm>
-          <a:prstGeom prst="rect">
-            <a:avLst/>
-          </a:prstGeom>
-          <a:noFill/>
-        </p:spPr>
-        <p:txBody>
-          <a:bodyPr wrap="square">
+            <a:off x="137160" y="6583680"/>
+            <a:ext cx="8869680" cy="256032"/>
+          </a:xfrm>
+          <a:prstGeom prst="rect">
+            <a:avLst/>
+          </a:prstGeom>
+          <a:noFill/>
+        </p:spPr>
+        <p:txBody>
+          <a:bodyPr wrap="none">
             <a:spAutoFit/>
           </a:bodyPr>
           <a:lstStyle/>
           <a:p>
             <a:pPr algn="ctr"/>
             <a:r>
-              <a:rPr sz="1000" i="1">
-                <a:solidFill>
-                  <a:srgbClr val="90B4CE"/>
-                </a:solidFill>
-              </a:rPr>
-              <a:t>SWaT testbed: 6-stage water treatment system targeted in this research</a:t>
+              <a:rPr sz="900" i="1">
+                <a:solidFill>
+                  <a:srgbClr val="7090B0"/>
+                </a:solidFill>
+              </a:rPr>
+              <a:t>SWaT testbed: 6-stage water treatment system targeted in this research — iTrust Lab, SUTD</a:t>
             </a:r>
           </a:p>
         </p:txBody>

</xml_diff>